<commit_message>
Add Table of Figures and Tables to report, replace em-dashes, and polish executive presentation slides
</commit_message>
<xml_diff>
--- a/docs/INLANEFREIGHT_AD_Compromise_Presentation.pptx
+++ b/docs/INLANEFREIGHT_AD_Compromise_Presentation.pptx
@@ -3092,7 +3092,7 @@
     <p:bg>
       <p:bgPr>
         <a:solidFill>
-          <a:srgbClr val="F9F8F5"/>
+          <a:srgbClr val="F8F9FA"/>
         </a:solidFill>
         <a:effectLst/>
       </p:bgPr>
@@ -3106,16 +3106,16 @@
       <p:grpSpPr/>
       <p:sp>
         <p:nvSpPr>
-          <p:cNvPr id="2" name="Rectangle 1"/>
+          <p:cNvPr id="2" name="Rounded Rectangle 1"/>
           <p:cNvSpPr/>
           <p:nvPr/>
         </p:nvSpPr>
         <p:spPr>
           <a:xfrm>
             <a:off x="731520" y="1371600"/>
-            <a:ext cx="228600" cy="4114800"/>
+            <a:ext cx="274320" cy="4389120"/>
           </a:xfrm>
-          <a:prstGeom prst="rect">
+          <a:prstGeom prst="roundRect">
             <a:avLst/>
           </a:prstGeom>
           <a:solidFill>
@@ -3155,8 +3155,8 @@
         </p:nvSpPr>
         <p:spPr>
           <a:xfrm>
-            <a:off x="1188720" y="1371600"/>
-            <a:ext cx="10058400" cy="2286000"/>
+            <a:off x="1188720" y="1280160"/>
+            <a:ext cx="10058400" cy="2377440"/>
           </a:xfrm>
           <a:prstGeom prst="rect">
             <a:avLst/>
@@ -3208,7 +3208,7 @@
               </a:defRPr>
             </a:pPr>
             <a:r>
-              <a:t>Active Directory Assumed-Breach Penetration Test &amp; DCSync Attack Chain (INLANEFREIGHT.LOCAL)</a:t>
+              <a:t>An Assumed-Breach Active Directory Penetration Test of INLANEFREIGHT.LOCAL</a:t>
             </a:r>
           </a:p>
         </p:txBody>
@@ -3222,7 +3222,7 @@
         <p:spPr>
           <a:xfrm>
             <a:off x="1188720" y="3931920"/>
-            <a:ext cx="10058400" cy="1645920"/>
+            <a:ext cx="10058400" cy="1828800"/>
           </a:xfrm>
           <a:prstGeom prst="roundRect">
             <a:avLst/>
@@ -3255,7 +3255,7 @@
           <a:lstStyle/>
           <a:p>
             <a:pPr algn="ctr">
-              <a:defRPr sz="1300" b="1">
+              <a:defRPr sz="1400" b="1">
                 <a:solidFill>
                   <a:srgbClr val="0F6E66"/>
                 </a:solidFill>
@@ -3263,7 +3263,7 @@
               </a:defRPr>
             </a:pPr>
             <a:r>
-              <a:t>Presenter: Enoch Nana Tabi Oduro  |  Index: CY376-2026-REG  |  Track: Red Team</a:t>
+              <a:t>Presenter: Enoch Nana Tabi Oduro  |  Index: CY376-2026-REG  |  Track: Red Team Assessment</a:t>
             </a:r>
           </a:p>
           <a:p>
@@ -3308,7 +3308,7 @@
     <p:bg>
       <p:bgPr>
         <a:solidFill>
-          <a:srgbClr val="F9F8F5"/>
+          <a:srgbClr val="F8F9FA"/>
         </a:solidFill>
         <a:effectLst/>
       </p:bgPr>
@@ -3322,23 +3322,25 @@
       <p:grpSpPr/>
       <p:sp>
         <p:nvSpPr>
-          <p:cNvPr id="2" name="Rectangle 1"/>
+          <p:cNvPr id="2" name="Rounded Rectangle 1"/>
           <p:cNvSpPr/>
           <p:nvPr/>
         </p:nvSpPr>
         <p:spPr>
           <a:xfrm>
-            <a:off x="731520" y="457200"/>
-            <a:ext cx="10728655" cy="914400"/>
+            <a:off x="731520" y="365760"/>
+            <a:ext cx="10728655" cy="960120"/>
           </a:xfrm>
-          <a:prstGeom prst="rect">
+          <a:prstGeom prst="roundRect">
             <a:avLst/>
           </a:prstGeom>
           <a:solidFill>
             <a:srgbClr val="E6F2F0"/>
           </a:solidFill>
-          <a:ln>
-            <a:noFill/>
+          <a:ln w="12700">
+            <a:solidFill>
+              <a:srgbClr val="0D9488"/>
+            </a:solidFill>
           </a:ln>
         </p:spPr>
         <p:style>
@@ -3368,7 +3370,7 @@
               </a:defRPr>
             </a:pPr>
             <a:r>
-              <a:t>CY376 RED TEAM PRESENTATION</a:t>
+              <a:t>CY376 RED TEAM BRIEFING</a:t>
             </a:r>
           </a:p>
           <a:p>
@@ -3381,7 +3383,7 @@
               </a:defRPr>
             </a:pPr>
             <a:r>
-              <a:t>1. Engagement Objectives &amp; Threat Model</a:t>
+              <a:t>1. Engagement Scope &amp; Assumed-Breach Threat Model</a:t>
             </a:r>
           </a:p>
         </p:txBody>
@@ -3403,9 +3405,9 @@
           <a:solidFill>
             <a:srgbClr val="FFFFFF"/>
           </a:solidFill>
-          <a:ln>
+          <a:ln w="15240">
             <a:solidFill>
-              <a:srgbClr val="E6F2F0"/>
+              <a:srgbClr val="CBD5E1"/>
             </a:solidFill>
           </a:ln>
         </p:spPr>
@@ -3436,30 +3438,48 @@
               </a:defRPr>
             </a:pPr>
             <a:r>
-              <a:t>Assumed-Breach Threat Model</a:t>
-            </a:r>
-          </a:p>
-          <a:p>
-            <a:r>
-              <a:rPr b="1" sz="1300">
+              <a:t>Assumed-Breach Threat Strategy</a:t>
+            </a:r>
+          </a:p>
+          <a:p>
+            <a:r>
+              <a:rPr b="1" sz="1200">
                 <a:solidFill>
                   <a:srgbClr val="1E293B"/>
                 </a:solidFill>
               </a:rPr>
-              <a:t>Insider Threat Simulation: </a:t>
-            </a:r>
-            <a:r>
-              <a:rPr sz="1300">
+              <a:t>Realistic Threat Model: </a:t>
+            </a:r>
+            <a:r>
+              <a:rPr sz="1150">
                 <a:solidFill>
                   <a:srgbClr val="475569"/>
                 </a:solidFill>
               </a:rPr>
-              <a:t>Assumes an attacker has achieved internal network access and obtained low-privilege credentials (hporter).</a:t>
-            </a:r>
-          </a:p>
-          <a:p>
-            <a:r>
-              <a:rPr b="1" sz="1300">
+              <a:t>Simulates an insider threat or an adversary with an established internal network foothold.</a:t>
+            </a:r>
+          </a:p>
+          <a:p>
+            <a:r>
+              <a:rPr b="1" sz="1200">
+                <a:solidFill>
+                  <a:srgbClr val="1E293B"/>
+                </a:solidFill>
+              </a:rPr>
+              <a:t>Starting Credential: </a:t>
+            </a:r>
+            <a:r>
+              <a:rPr sz="1150">
+                <a:solidFill>
+                  <a:srgbClr val="475569"/>
+                </a:solidFill>
+              </a:rPr>
+              <a:t>Low-privileged user hporter : Gr8hambino! on INLANEFREIGHT.LOCAL.</a:t>
+            </a:r>
+          </a:p>
+          <a:p>
+            <a:r>
+              <a:rPr b="1" sz="1200">
                 <a:solidFill>
                   <a:srgbClr val="1E293B"/>
                 </a:solidFill>
@@ -3467,17 +3487,17 @@
               <a:t>Perimeter Bypass: </a:t>
             </a:r>
             <a:r>
-              <a:rPr sz="1300">
+              <a:rPr sz="1150">
                 <a:solidFill>
                   <a:srgbClr val="475569"/>
                 </a:solidFill>
               </a:rPr>
-              <a:t>Focuses strictly on internal defense-in-depth, object ACL delegations, service isolation, and directory security.</a:t>
-            </a:r>
-          </a:p>
-          <a:p>
-            <a:r>
-              <a:rPr b="1" sz="1300">
+              <a:t>Focuses evaluation strictly on internal AD object permissions, service isolation, and delegation oversights.</a:t>
+            </a:r>
+          </a:p>
+          <a:p>
+            <a:r>
+              <a:rPr b="1" sz="1200">
                 <a:solidFill>
                   <a:srgbClr val="1E293B"/>
                 </a:solidFill>
@@ -3485,12 +3505,12 @@
               <a:t>Zero-Day Independent: </a:t>
             </a:r>
             <a:r>
-              <a:rPr sz="1300">
+              <a:rPr sz="1150">
                 <a:solidFill>
                   <a:srgbClr val="475569"/>
                 </a:solidFill>
               </a:rPr>
-              <a:t>Evaluates how native Windows features, misconfigurations, and credential hygiene failures lead to compromise.</a:t>
+              <a:t>Proves how native Windows protocols and ACL flaws concatenate into full domain compromise.</a:t>
             </a:r>
           </a:p>
         </p:txBody>
@@ -3512,8 +3532,10 @@
           <a:solidFill>
             <a:srgbClr val="E6F2F0"/>
           </a:solidFill>
-          <a:ln>
-            <a:noFill/>
+          <a:ln w="15240">
+            <a:solidFill>
+              <a:srgbClr val="0D9488"/>
+            </a:solidFill>
           </a:ln>
         </p:spPr>
         <p:style>
@@ -3543,12 +3565,12 @@
               </a:defRPr>
             </a:pPr>
             <a:r>
-              <a:t>Primary Research Questions</a:t>
+              <a:t>Primary Engagement Objectives</a:t>
             </a:r>
           </a:p>
           <a:p>
             <a:pPr>
-              <a:defRPr sz="1300">
+              <a:defRPr sz="1150">
                 <a:solidFill>
                   <a:srgbClr val="1E293B"/>
                 </a:solidFill>
@@ -3556,12 +3578,12 @@
               </a:defRPr>
             </a:pPr>
             <a:r>
-              <a:t>1. Can a single unprivileged domain user (hporter) achieve full Domain Administrator rights through ACL misconfiguration chaining?</a:t>
+              <a:t>1. Privilege Escalation Validation: Determine if low-privileged hporter can reach Domain Administrator rights.</a:t>
             </a:r>
           </a:p>
           <a:p>
             <a:pPr>
-              <a:defRPr sz="1300">
+              <a:defRPr sz="1150">
                 <a:solidFill>
                   <a:srgbClr val="1E293B"/>
                 </a:solidFill>
@@ -3569,12 +3591,12 @@
               </a:defRPr>
             </a:pPr>
             <a:r>
-              <a:t>2. How do decoupled security flaws (file share scripts, autologon secrets, vulnerable local services) concatenate into a full attack path?</a:t>
+              <a:t>2. Structural Misconfiguration Audit: Map ACL oversights (ForceChangePassword, GenericWrite, GenericAll).</a:t>
             </a:r>
           </a:p>
           <a:p>
             <a:pPr>
-              <a:defRPr sz="1300">
+              <a:defRPr sz="1150">
                 <a:solidFill>
                   <a:srgbClr val="1E293B"/>
                 </a:solidFill>
@@ -3582,7 +3604,33 @@
               </a:defRPr>
             </a:pPr>
             <a:r>
-              <a:t>3. What is the operational impact of unmonitored directory replication rights (GetChanges / GetChangesAll) on domain integrity?</a:t>
+              <a:t>3. Credential Hygiene Assessment: Identify cleartext credentials in scripts, unattend files, and LSA autologon registry secrets.</a:t>
+            </a:r>
+          </a:p>
+          <a:p>
+            <a:pPr>
+              <a:defRPr sz="1150">
+                <a:solidFill>
+                  <a:srgbClr val="1E293B"/>
+                </a:solidFill>
+                <a:latin typeface="Calibri"/>
+              </a:defRPr>
+            </a:pPr>
+            <a:r>
+              <a:t>4. DCSync Replication Impact: Demonstrate business risk of unmonitored GetChanges / GetChangesAll replication rights.</a:t>
+            </a:r>
+          </a:p>
+          <a:p>
+            <a:pPr>
+              <a:defRPr sz="1150">
+                <a:solidFill>
+                  <a:srgbClr val="1E293B"/>
+                </a:solidFill>
+                <a:latin typeface="Calibri"/>
+              </a:defRPr>
+            </a:pPr>
+            <a:r>
+              <a:t>5. Defensive Hardening Roadmap: Formulate prioritized remediations aligned with CIS Benchmarks &amp; MITRE ATT&amp;CK.</a:t>
             </a:r>
           </a:p>
         </p:txBody>
@@ -3601,7 +3649,7 @@
     <p:bg>
       <p:bgPr>
         <a:solidFill>
-          <a:srgbClr val="F9F8F5"/>
+          <a:srgbClr val="F8F9FA"/>
         </a:solidFill>
         <a:effectLst/>
       </p:bgPr>
@@ -3615,23 +3663,25 @@
       <p:grpSpPr/>
       <p:sp>
         <p:nvSpPr>
-          <p:cNvPr id="2" name="Rectangle 1"/>
+          <p:cNvPr id="2" name="Rounded Rectangle 1"/>
           <p:cNvSpPr/>
           <p:nvPr/>
         </p:nvSpPr>
         <p:spPr>
           <a:xfrm>
-            <a:off x="731520" y="457200"/>
-            <a:ext cx="10728655" cy="914400"/>
+            <a:off x="731520" y="365760"/>
+            <a:ext cx="10728655" cy="960120"/>
           </a:xfrm>
-          <a:prstGeom prst="rect">
+          <a:prstGeom prst="roundRect">
             <a:avLst/>
           </a:prstGeom>
           <a:solidFill>
             <a:srgbClr val="E6F2F0"/>
           </a:solidFill>
-          <a:ln>
-            <a:noFill/>
+          <a:ln w="12700">
+            <a:solidFill>
+              <a:srgbClr val="0D9488"/>
+            </a:solidFill>
           </a:ln>
         </p:spPr>
         <p:style>
@@ -3661,7 +3711,7 @@
               </a:defRPr>
             </a:pPr>
             <a:r>
-              <a:t>CY376 RED TEAM PRESENTATION</a:t>
+              <a:t>CY376 RED TEAM BRIEFING</a:t>
             </a:r>
           </a:p>
           <a:p>
@@ -3674,7 +3724,7 @@
               </a:defRPr>
             </a:pPr>
             <a:r>
-              <a:t>2. Lab Architecture &amp; Target Environment Setup</a:t>
+              <a:t>2. Lab Target Environment &amp; Network Architecture</a:t>
             </a:r>
           </a:p>
         </p:txBody>
@@ -3734,7 +3784,7 @@
           </a:p>
           <a:p>
             <a:pPr>
-              <a:defRPr sz="1200" b="1">
+              <a:defRPr sz="1150" b="1">
                 <a:solidFill>
                   <a:srgbClr val="475569"/>
                 </a:solidFill>
@@ -3747,7 +3797,7 @@
           </a:p>
           <a:p>
             <a:pPr>
-              <a:defRPr sz="1150">
+              <a:defRPr sz="1100">
                 <a:solidFill>
                   <a:srgbClr val="1E293B"/>
                 </a:solidFill>
@@ -3755,7 +3805,7 @@
               </a:defRPr>
             </a:pPr>
             <a:r>
-              <a:t>Target Domain Controller hosting INLANEFREIGHT.LOCAL AD services, LDAP, DNS, and KDC.</a:t>
+              <a:t>Primary Active Directory Domain Controller for INLANEFREIGHT.LOCAL. KDC, LDAP, and DNS server.</a:t>
             </a:r>
           </a:p>
         </p:txBody>
@@ -3815,7 +3865,7 @@
           </a:p>
           <a:p>
             <a:pPr>
-              <a:defRPr sz="1200" b="1">
+              <a:defRPr sz="1150" b="1">
                 <a:solidFill>
                   <a:srgbClr val="475569"/>
                 </a:solidFill>
@@ -3828,7 +3878,7 @@
           </a:p>
           <a:p>
             <a:pPr>
-              <a:defRPr sz="1150">
+              <a:defRPr sz="1100">
                 <a:solidFill>
                   <a:srgbClr val="1E293B"/>
                 </a:solidFill>
@@ -3836,7 +3886,7 @@
               </a:defRPr>
             </a:pPr>
             <a:r>
-              <a:t>Application server hosting WinRM, SQL Express backup routines, and Sysax Automation Service.</a:t>
+              <a:t>General-purpose member server hosting WinRM, SQL Express backup routines, and Sysax Automation Service.</a:t>
             </a:r>
           </a:p>
         </p:txBody>
@@ -3896,7 +3946,7 @@
           </a:p>
           <a:p>
             <a:pPr>
-              <a:defRPr sz="1200" b="1">
+              <a:defRPr sz="1150" b="1">
                 <a:solidFill>
                   <a:srgbClr val="475569"/>
                 </a:solidFill>
@@ -3909,7 +3959,7 @@
           </a:p>
           <a:p>
             <a:pPr>
-              <a:defRPr sz="1150">
+              <a:defRPr sz="1100">
                 <a:solidFill>
                   <a:srgbClr val="1E293B"/>
                 </a:solidFill>
@@ -3972,12 +4022,12 @@
               </a:defRPr>
             </a:pPr>
             <a:r>
-              <a:t>Attacker Host (172.16.8.100)</a:t>
+              <a:t>Attacker Station (172.16.8.100)</a:t>
             </a:r>
           </a:p>
           <a:p>
             <a:pPr>
-              <a:defRPr sz="1200" b="1">
+              <a:defRPr sz="1150" b="1">
                 <a:solidFill>
                   <a:srgbClr val="475569"/>
                 </a:solidFill>
@@ -3985,12 +4035,12 @@
               </a:defRPr>
             </a:pPr>
             <a:r>
-              <a:t>Role: Red Team Station  |  OS: Kali Linux 2026.2</a:t>
+              <a:t>Role: Red Team Platform  |  OS: Kali Linux 2026.2</a:t>
             </a:r>
           </a:p>
           <a:p>
             <a:pPr>
-              <a:defRPr sz="1150">
+              <a:defRPr sz="1100">
                 <a:solidFill>
                   <a:srgbClr val="1E293B"/>
                 </a:solidFill>
@@ -4017,7 +4067,7 @@
     <p:bg>
       <p:bgPr>
         <a:solidFill>
-          <a:srgbClr val="F9F8F5"/>
+          <a:srgbClr val="F8F9FA"/>
         </a:solidFill>
         <a:effectLst/>
       </p:bgPr>
@@ -4031,23 +4081,25 @@
       <p:grpSpPr/>
       <p:sp>
         <p:nvSpPr>
-          <p:cNvPr id="2" name="Rectangle 1"/>
+          <p:cNvPr id="2" name="Rounded Rectangle 1"/>
           <p:cNvSpPr/>
           <p:nvPr/>
         </p:nvSpPr>
         <p:spPr>
           <a:xfrm>
-            <a:off x="731520" y="457200"/>
-            <a:ext cx="10728655" cy="914400"/>
+            <a:off x="731520" y="365760"/>
+            <a:ext cx="10728655" cy="960120"/>
           </a:xfrm>
-          <a:prstGeom prst="rect">
+          <a:prstGeom prst="roundRect">
             <a:avLst/>
           </a:prstGeom>
           <a:solidFill>
             <a:srgbClr val="E6F2F0"/>
           </a:solidFill>
-          <a:ln>
-            <a:noFill/>
+          <a:ln w="12700">
+            <a:solidFill>
+              <a:srgbClr val="0D9488"/>
+            </a:solidFill>
           </a:ln>
         </p:spPr>
         <p:style>
@@ -4077,7 +4129,7 @@
               </a:defRPr>
             </a:pPr>
             <a:r>
-              <a:t>CY376 RED TEAM PRESENTATION</a:t>
+              <a:t>CY376 RED TEAM BRIEFING</a:t>
             </a:r>
           </a:p>
           <a:p>
@@ -4090,7 +4142,7 @@
               </a:defRPr>
             </a:pPr>
             <a:r>
-              <a:t>3. Results: Foothold Verification to Host Compromise</a:t>
+              <a:t>3. Attack Chain Phase 1: Foothold Verification &amp; Host Compromise</a:t>
             </a:r>
           </a:p>
         </p:txBody>
@@ -4114,7 +4166,7 @@
           </a:solidFill>
           <a:ln>
             <a:solidFill>
-              <a:srgbClr val="E6F2F0"/>
+              <a:srgbClr val="CBD5E1"/>
             </a:solidFill>
           </a:ln>
         </p:spPr>
@@ -4138,7 +4190,7 @@
           <a:p>
             <a:pPr algn="ctr"/>
             <a:r>
-              <a:rPr b="1" sz="1250">
+              <a:rPr b="1" sz="1200">
                 <a:solidFill>
                   <a:srgbClr val="0F6E66"/>
                 </a:solidFill>
@@ -4147,18 +4199,18 @@
 </a:t>
             </a:r>
             <a:r>
-              <a:rPr sz="1150">
+              <a:rPr sz="1100">
                 <a:solidFill>
                   <a:srgbClr val="1E293B"/>
                 </a:solidFill>
               </a:rPr>
-              <a:t>Confirmed hporter : Gr8hambino! credentials via NetExec SMB on DC01.
+              <a:t>Validated hporter : Gr8hambino! credentials against DC01 via NetExec SMB.
 </a:t>
             </a:r>
           </a:p>
           <a:p>
             <a:r>
-              <a:rPr b="1" sz="1250">
+              <a:rPr b="1" sz="1200">
                 <a:solidFill>
                   <a:srgbClr val="0F6E66"/>
                 </a:solidFill>
@@ -4167,18 +4219,18 @@
 </a:t>
             </a:r>
             <a:r>
-              <a:rPr sz="1150">
+              <a:rPr sz="1100">
                 <a:solidFill>
                   <a:srgbClr val="1E293B"/>
                 </a:solidFill>
               </a:rPr>
-              <a:t>BloodHound revealed ForceChangePassword over ssmalls. Reset password to mazoniakid via bloodyAD.
+              <a:t>BloodHound graph analysis exposed ForceChangePassword over ssmalls. Forcefully updated password to mazoniakid via bloodyAD.
 </a:t>
             </a:r>
           </a:p>
           <a:p>
             <a:r>
-              <a:rPr b="1" sz="1250">
+              <a:rPr b="1" sz="1200">
                 <a:solidFill>
                   <a:srgbClr val="0F6E66"/>
                 </a:solidFill>
@@ -4187,18 +4239,18 @@
 </a:t>
             </a:r>
             <a:r>
-              <a:rPr sz="1150">
+              <a:rPr sz="1100">
                 <a:solidFill>
                   <a:srgbClr val="1E293B"/>
                 </a:solidFill>
               </a:rPr>
-              <a:t>Spidered IT department share as ssmalls; extracted backupadm credentials from SQL Express Backup.ps1.
+              <a:t>Spidered IT department share as ssmalls; extracted backupadm : !qazXSW@ from SQL Express Backup.ps1.
 </a:t>
             </a:r>
           </a:p>
           <a:p>
             <a:r>
-              <a:rPr b="1" sz="1250">
+              <a:rPr b="1" sz="1200">
                 <a:solidFill>
                   <a:srgbClr val="0F6E66"/>
                 </a:solidFill>
@@ -4207,32 +4259,32 @@
 </a:t>
             </a:r>
             <a:r>
-              <a:rPr sz="1150">
+              <a:rPr sz="1100">
                 <a:solidFill>
                   <a:srgbClr val="1E293B"/>
                 </a:solidFill>
               </a:rPr>
-              <a:t>Authenticated to MS01 via WinRM using backupadm credentials.
+              <a:t>Authenticated to member server MS01 via WinRM using backupadm credentials.
 </a:t>
             </a:r>
           </a:p>
           <a:p>
             <a:r>
-              <a:rPr b="1" sz="1250">
+              <a:rPr b="1" sz="1200">
                 <a:solidFill>
                   <a:srgbClr val="0F6E66"/>
                 </a:solidFill>
               </a:rPr>
-              <a:t>Stage 6-7: Unattend.xml &amp; Sysax Service LPE
+              <a:t>Stage 6-7: Unattend.xml &amp; Sysax LPE
 </a:t>
             </a:r>
             <a:r>
-              <a:rPr sz="1150">
+              <a:rPr sz="1100">
                 <a:solidFill>
                   <a:srgbClr val="1E293B"/>
                 </a:solidFill>
               </a:rPr>
-              <a:t>Harvested ilfserveradm credentials from C:\panther\unattend.xml; escalated to local SYSTEM via vulnerable Sysax service.
+              <a:t>Discovered cleartext ilfserveradm credentials in C:\panther\unattend.xml. Escalated to local SYSTEM via vulnerable Sysax Automation service.
 </a:t>
             </a:r>
           </a:p>
@@ -4300,7 +4352,7 @@
     <p:bg>
       <p:bgPr>
         <a:solidFill>
-          <a:srgbClr val="F9F8F5"/>
+          <a:srgbClr val="F8F9FA"/>
         </a:solidFill>
         <a:effectLst/>
       </p:bgPr>
@@ -4314,23 +4366,25 @@
       <p:grpSpPr/>
       <p:sp>
         <p:nvSpPr>
-          <p:cNvPr id="2" name="Rectangle 1"/>
+          <p:cNvPr id="2" name="Rounded Rectangle 1"/>
           <p:cNvSpPr/>
           <p:nvPr/>
         </p:nvSpPr>
         <p:spPr>
           <a:xfrm>
-            <a:off x="731520" y="457200"/>
-            <a:ext cx="10728655" cy="914400"/>
+            <a:off x="731520" y="365760"/>
+            <a:ext cx="10728655" cy="960120"/>
           </a:xfrm>
-          <a:prstGeom prst="rect">
+          <a:prstGeom prst="roundRect">
             <a:avLst/>
           </a:prstGeom>
           <a:solidFill>
             <a:srgbClr val="E6F2F0"/>
           </a:solidFill>
-          <a:ln>
-            <a:noFill/>
+          <a:ln w="12700">
+            <a:solidFill>
+              <a:srgbClr val="0D9488"/>
+            </a:solidFill>
           </a:ln>
         </p:spPr>
         <p:style>
@@ -4360,7 +4414,7 @@
               </a:defRPr>
             </a:pPr>
             <a:r>
-              <a:t>CY376 RED TEAM PRESENTATION</a:t>
+              <a:t>CY376 RED TEAM BRIEFING</a:t>
             </a:r>
           </a:p>
           <a:p>
@@ -4373,7 +4427,7 @@
               </a:defRPr>
             </a:pPr>
             <a:r>
-              <a:t>4. Results: LSA Autologon Secrets &amp; Targeted Kerberoasting</a:t>
+              <a:t>4. Attack Chain Phase 2: LSA Autologon Secrets &amp; Targeted Kerberoasting</a:t>
             </a:r>
           </a:p>
         </p:txBody>
@@ -4397,7 +4451,7 @@
           </a:solidFill>
           <a:ln>
             <a:solidFill>
-              <a:srgbClr val="E6F2F0"/>
+              <a:srgbClr val="CBD5E1"/>
             </a:solidFill>
           </a:ln>
         </p:spPr>
@@ -4421,7 +4475,7 @@
           <a:p>
             <a:pPr algn="ctr"/>
             <a:r>
-              <a:rPr b="1" sz="1300">
+              <a:rPr b="1" sz="1250">
                 <a:solidFill>
                   <a:srgbClr val="0F6E66"/>
                 </a:solidFill>
@@ -4430,18 +4484,18 @@
 </a:t>
             </a:r>
             <a:r>
-              <a:rPr sz="1200">
+              <a:rPr sz="1150">
                 <a:solidFill>
                   <a:srgbClr val="1E293B"/>
                 </a:solidFill>
               </a:rPr>
-              <a:t>Extracted cleartext autologon registry secrets on MS01; recovered mssqladm : DBAilfreight1!.
+              <a:t>Extracted cleartext autologon registry secrets (HKLM\SECURITY) on MS01; recovered domain service account mssqladm : DBAilfreight1!.
 </a:t>
             </a:r>
           </a:p>
           <a:p>
             <a:r>
-              <a:rPr b="1" sz="1300">
+              <a:rPr b="1" sz="1250">
                 <a:solidFill>
                   <a:srgbClr val="0F6E66"/>
                 </a:solidFill>
@@ -4450,32 +4504,32 @@
 </a:t>
             </a:r>
             <a:r>
-              <a:rPr sz="1200">
+              <a:rPr sz="1150">
                 <a:solidFill>
                   <a:srgbClr val="1E293B"/>
                 </a:solidFill>
               </a:rPr>
-              <a:t>mssqladm held GenericWrite over user ttimmons. Injected fake SPN (acmetesting/LEGIT) using bloodyAD.
+              <a:t>mssqladm possessed GenericWrite rights over user ttimmons. Used bloodyAD to write a fake Service Principal Name (acmetesting/LEGIT), forcing ttimmons to become Kerberoastable.
 </a:t>
             </a:r>
           </a:p>
           <a:p>
             <a:r>
-              <a:rPr b="1" sz="1300">
+              <a:rPr b="1" sz="1250">
                 <a:solidFill>
                   <a:srgbClr val="0F6E66"/>
                 </a:solidFill>
               </a:rPr>
-              <a:t>Offline Kerberos TGS Cracking
+              <a:t>Offline Kerberos TGS Ticket Cracking
 </a:t>
             </a:r>
             <a:r>
-              <a:rPr sz="1200">
+              <a:rPr sz="1150">
                 <a:solidFill>
                   <a:srgbClr val="1E293B"/>
                 </a:solidFill>
               </a:rPr>
-              <a:t>Requested TGS ticket via Impacket GetUserSPNs.py; cracked password Repeat09 offline via Hashcat (Mode 13100).
+              <a:t>Requested TGS ticket via Impacket GetUserSPNs.py. Cracked Kerberos hash offline via Hashcat (Mode 13100), recovering ttimmons : Repeat09.
 </a:t>
             </a:r>
           </a:p>
@@ -4521,7 +4575,7 @@
         </p:blipFill>
         <p:spPr>
           <a:xfrm>
-            <a:off x="4114800" y="4023360"/>
+            <a:off x="6492240" y="4023360"/>
             <a:ext cx="4937760" cy="1918517"/>
           </a:xfrm>
           <a:prstGeom prst="rect">
@@ -4543,7 +4597,7 @@
     <p:bg>
       <p:bgPr>
         <a:solidFill>
-          <a:srgbClr val="F9F8F5"/>
+          <a:srgbClr val="F8F9FA"/>
         </a:solidFill>
         <a:effectLst/>
       </p:bgPr>
@@ -4557,23 +4611,25 @@
       <p:grpSpPr/>
       <p:sp>
         <p:nvSpPr>
-          <p:cNvPr id="2" name="Rectangle 1"/>
+          <p:cNvPr id="2" name="Rounded Rectangle 1"/>
           <p:cNvSpPr/>
           <p:nvPr/>
         </p:nvSpPr>
         <p:spPr>
           <a:xfrm>
-            <a:off x="731520" y="457200"/>
-            <a:ext cx="10728655" cy="914400"/>
+            <a:off x="731520" y="365760"/>
+            <a:ext cx="10728655" cy="960120"/>
           </a:xfrm>
-          <a:prstGeom prst="rect">
+          <a:prstGeom prst="roundRect">
             <a:avLst/>
           </a:prstGeom>
           <a:solidFill>
             <a:srgbClr val="E6F2F0"/>
           </a:solidFill>
-          <a:ln>
-            <a:noFill/>
+          <a:ln w="12700">
+            <a:solidFill>
+              <a:srgbClr val="0D9488"/>
+            </a:solidFill>
           </a:ln>
         </p:spPr>
         <p:style>
@@ -4603,7 +4659,7 @@
               </a:defRPr>
             </a:pPr>
             <a:r>
-              <a:t>CY376 RED TEAM PRESENTATION</a:t>
+              <a:t>CY376 RED TEAM BRIEFING</a:t>
             </a:r>
           </a:p>
           <a:p>
@@ -4616,7 +4672,7 @@
               </a:defRPr>
             </a:pPr>
             <a:r>
-              <a:t>5. Results: Group Self-Addition &amp; DCSync Domain Compromise</a:t>
+              <a:t>5. Attack Chain Phase 3: Group Self-Addition &amp; DCSync Domain Takeover</a:t>
             </a:r>
           </a:p>
         </p:txBody>
@@ -4640,7 +4696,7 @@
           </a:solidFill>
           <a:ln>
             <a:solidFill>
-              <a:srgbClr val="E6F2F0"/>
+              <a:srgbClr val="CBD5E1"/>
             </a:solidFill>
           </a:ln>
         </p:spPr>
@@ -4664,27 +4720,27 @@
           <a:p>
             <a:pPr algn="ctr"/>
             <a:r>
-              <a:rPr b="1" sz="1300">
+              <a:rPr b="1" sz="1250">
                 <a:solidFill>
                   <a:srgbClr val="0F6E66"/>
                 </a:solidFill>
               </a:rPr>
-              <a:t>Stage 10: Group Self-Addition
+              <a:t>Stage 10: Server Admins Group Self-Addition
 </a:t>
             </a:r>
             <a:r>
-              <a:rPr sz="1200">
+              <a:rPr sz="1150">
                 <a:solidFill>
                   <a:srgbClr val="1E293B"/>
                 </a:solidFill>
               </a:rPr>
-              <a:t>ttimmons held GenericAll control over Server Admins group; added itself directly into the group.
+              <a:t>ttimmons possessed GenericAll control over the Server Admins security group. Used bloodyAD to self-add ttimmons directly into Server Admins.
 </a:t>
             </a:r>
           </a:p>
           <a:p>
             <a:r>
-              <a:rPr b="1" sz="1300">
+              <a:rPr b="1" sz="1250">
                 <a:solidFill>
                   <a:srgbClr val="0F6E66"/>
                 </a:solidFill>
@@ -4693,18 +4749,18 @@
 </a:t>
             </a:r>
             <a:r>
-              <a:rPr sz="1200">
+              <a:rPr sz="1150">
                 <a:solidFill>
                   <a:srgbClr val="1E293B"/>
                 </a:solidFill>
               </a:rPr>
-              <a:t>Server Admins group held GetChanges/GetChangesAll rights on domain root. Dumped NTDS.DIT database via secretsdump.py.
+              <a:t>Server Admins group held GetChanges/GetChangesAll replication rights on the domain root. Dumped full NTDS.DIT database via secretsdump.py (Administrator hash: fd1f7e5564060258ea787ddbb6e6afa2).
 </a:t>
             </a:r>
           </a:p>
           <a:p>
             <a:r>
-              <a:rPr b="1" sz="1300">
+              <a:rPr b="1" sz="1250">
                 <a:solidFill>
                   <a:srgbClr val="0F6E66"/>
                 </a:solidFill>
@@ -4713,12 +4769,12 @@
 </a:t>
             </a:r>
             <a:r>
-              <a:rPr sz="1200">
+              <a:rPr sz="1150">
                 <a:solidFill>
                   <a:srgbClr val="1E293B"/>
                 </a:solidFill>
               </a:rPr>
-              <a:t>Authenticated to DC01 via WinRM using Administrator NTLM hash (fd1f7e5564060258ea787ddbb6e6afa2), confirming 100% domain takeover.
+              <a:t>Authenticated directly to Domain Controller DC01 via WinRM using the extracted Administrator NTLM hash, confirming 100% domain takeover.
 </a:t>
             </a:r>
           </a:p>
@@ -4786,7 +4842,7 @@
     <p:bg>
       <p:bgPr>
         <a:solidFill>
-          <a:srgbClr val="F9F8F5"/>
+          <a:srgbClr val="F8F9FA"/>
         </a:solidFill>
         <a:effectLst/>
       </p:bgPr>
@@ -4800,23 +4856,25 @@
       <p:grpSpPr/>
       <p:sp>
         <p:nvSpPr>
-          <p:cNvPr id="2" name="Rectangle 1"/>
+          <p:cNvPr id="2" name="Rounded Rectangle 1"/>
           <p:cNvSpPr/>
           <p:nvPr/>
         </p:nvSpPr>
         <p:spPr>
           <a:xfrm>
-            <a:off x="731520" y="457200"/>
-            <a:ext cx="10728655" cy="914400"/>
+            <a:off x="731520" y="365760"/>
+            <a:ext cx="10728655" cy="960120"/>
           </a:xfrm>
-          <a:prstGeom prst="rect">
+          <a:prstGeom prst="roundRect">
             <a:avLst/>
           </a:prstGeom>
           <a:solidFill>
             <a:srgbClr val="E6F2F0"/>
           </a:solidFill>
-          <a:ln>
-            <a:noFill/>
+          <a:ln w="12700">
+            <a:solidFill>
+              <a:srgbClr val="0D9488"/>
+            </a:solidFill>
           </a:ln>
         </p:spPr>
         <p:style>
@@ -4846,7 +4904,7 @@
               </a:defRPr>
             </a:pPr>
             <a:r>
-              <a:t>CY376 RED TEAM PRESENTATION</a:t>
+              <a:t>CY376 RED TEAM BRIEFING</a:t>
             </a:r>
           </a:p>
           <a:p>
@@ -5984,7 +6042,7 @@
     <p:bg>
       <p:bgPr>
         <a:solidFill>
-          <a:srgbClr val="F9F8F5"/>
+          <a:srgbClr val="F8F9FA"/>
         </a:solidFill>
         <a:effectLst/>
       </p:bgPr>
@@ -5998,23 +6056,25 @@
       <p:grpSpPr/>
       <p:sp>
         <p:nvSpPr>
-          <p:cNvPr id="2" name="Rectangle 1"/>
+          <p:cNvPr id="2" name="Rounded Rectangle 1"/>
           <p:cNvSpPr/>
           <p:nvPr/>
         </p:nvSpPr>
         <p:spPr>
           <a:xfrm>
-            <a:off x="731520" y="457200"/>
-            <a:ext cx="10728655" cy="914400"/>
+            <a:off x="731520" y="365760"/>
+            <a:ext cx="10728655" cy="960120"/>
           </a:xfrm>
-          <a:prstGeom prst="rect">
+          <a:prstGeom prst="roundRect">
             <a:avLst/>
           </a:prstGeom>
           <a:solidFill>
             <a:srgbClr val="E6F2F0"/>
           </a:solidFill>
-          <a:ln>
-            <a:noFill/>
+          <a:ln w="12700">
+            <a:solidFill>
+              <a:srgbClr val="0D9488"/>
+            </a:solidFill>
           </a:ln>
         </p:spPr>
         <p:style>
@@ -6044,7 +6104,7 @@
               </a:defRPr>
             </a:pPr>
             <a:r>
-              <a:t>CY376 RED TEAM PRESENTATION</a:t>
+              <a:t>CY376 RED TEAM BRIEFING</a:t>
             </a:r>
           </a:p>
           <a:p>
@@ -6057,7 +6117,7 @@
               </a:defRPr>
             </a:pPr>
             <a:r>
-              <a:t>7. Prioritized Remediation Roadmap (CIS Benchmarks)</a:t>
+              <a:t>7. Prioritized Defensive Remediation Roadmap (CIS Benchmarks)</a:t>
             </a:r>
           </a:p>
         </p:txBody>
@@ -6112,12 +6172,12 @@
               </a:defRPr>
             </a:pPr>
             <a:r>
-              <a:t>1. Revoke Directory Replication Rights (Critical)</a:t>
+              <a:t>1. Revoke Directory Replication Rights (Immediate Critical Priority)</a:t>
             </a:r>
           </a:p>
           <a:p>
             <a:pPr>
-              <a:defRPr sz="1150">
+              <a:defRPr sz="1100">
                 <a:solidFill>
                   <a:srgbClr val="1E293B"/>
                 </a:solidFill>
@@ -6125,7 +6185,7 @@
               </a:defRPr>
             </a:pPr>
             <a:r>
-              <a:t>Immediately remove GetChanges and GetChangesAll replication rights from non-DC groups (Server Admins). Restrict replication to DCs only.</a:t>
+              <a:t>Immediately remove GetChanges and GetChangesAll replication rights from non-DC groups (Server Admins). Restrict replication exclusively to Domain Controllers.</a:t>
             </a:r>
           </a:p>
         </p:txBody>
@@ -6180,12 +6240,12 @@
               </a:defRPr>
             </a:pPr>
             <a:r>
-              <a:t>2. Remediate Excessive ACL Delegations (High)</a:t>
+              <a:t>2. Remediate Excessive ACL Delegations (High Priority)</a:t>
             </a:r>
           </a:p>
           <a:p>
             <a:pPr>
-              <a:defRPr sz="1150">
+              <a:defRPr sz="1100">
                 <a:solidFill>
                   <a:srgbClr val="1E293B"/>
                 </a:solidFill>
@@ -6193,7 +6253,7 @@
               </a:defRPr>
             </a:pPr>
             <a:r>
-              <a:t>Audit AD object ACLs via BloodHound Enterprise / PingCastle. Revoke ForceChangePassword, GenericWrite, and GenericAll from standard accounts.</a:t>
+              <a:t>Audit AD object ACLs via BloodHound Enterprise / PingCastle. Revoke ForceChangePassword, GenericWrite, and GenericAll from unprivileged accounts.</a:t>
             </a:r>
           </a:p>
         </p:txBody>
@@ -6248,12 +6308,12 @@
               </a:defRPr>
             </a:pPr>
             <a:r>
-              <a:t>3. Migrate Service Accounts to gMSAs (High)</a:t>
+              <a:t>3. Migrate Service Accounts to gMSAs (High Priority)</a:t>
             </a:r>
           </a:p>
           <a:p>
             <a:pPr>
-              <a:defRPr sz="1150">
+              <a:defRPr sz="1100">
                 <a:solidFill>
                   <a:srgbClr val="1E293B"/>
                 </a:solidFill>
@@ -6316,12 +6376,12 @@
               </a:defRPr>
             </a:pPr>
             <a:r>
-              <a:t>4. Enable LSA Protection &amp; Credential Guard (Medium)</a:t>
+              <a:t>4. Enable LSA Protection &amp; Credential Guard (Medium Priority)</a:t>
             </a:r>
           </a:p>
           <a:p>
             <a:pPr>
-              <a:defRPr sz="1150">
+              <a:defRPr sz="1100">
                 <a:solidFill>
                   <a:srgbClr val="1E293B"/>
                 </a:solidFill>
@@ -6384,12 +6444,12 @@
               </a:defRPr>
             </a:pPr>
             <a:r>
-              <a:t>5. Implement Microsoft Tiered Administration (Strategic)</a:t>
+              <a:t>5. Implement Microsoft Tiered Administration Model (Strategic Priority)</a:t>
             </a:r>
           </a:p>
           <a:p>
             <a:pPr>
-              <a:defRPr sz="1150">
+              <a:defRPr sz="1100">
                 <a:solidFill>
                   <a:srgbClr val="1E293B"/>
                 </a:solidFill>
@@ -6416,7 +6476,7 @@
     <p:bg>
       <p:bgPr>
         <a:solidFill>
-          <a:srgbClr val="F9F8F5"/>
+          <a:srgbClr val="F8F9FA"/>
         </a:solidFill>
         <a:effectLst/>
       </p:bgPr>
@@ -6430,23 +6490,25 @@
       <p:grpSpPr/>
       <p:sp>
         <p:nvSpPr>
-          <p:cNvPr id="2" name="Rectangle 1"/>
+          <p:cNvPr id="2" name="Rounded Rectangle 1"/>
           <p:cNvSpPr/>
           <p:nvPr/>
         </p:nvSpPr>
         <p:spPr>
           <a:xfrm>
-            <a:off x="731520" y="457200"/>
-            <a:ext cx="10728655" cy="914400"/>
+            <a:off x="731520" y="365760"/>
+            <a:ext cx="10728655" cy="960120"/>
           </a:xfrm>
-          <a:prstGeom prst="rect">
+          <a:prstGeom prst="roundRect">
             <a:avLst/>
           </a:prstGeom>
           <a:solidFill>
             <a:srgbClr val="E6F2F0"/>
           </a:solidFill>
-          <a:ln>
-            <a:noFill/>
+          <a:ln w="12700">
+            <a:solidFill>
+              <a:srgbClr val="0D9488"/>
+            </a:solidFill>
           </a:ln>
         </p:spPr>
         <p:style>
@@ -6476,7 +6538,7 @@
               </a:defRPr>
             </a:pPr>
             <a:r>
-              <a:t>CY376 RED TEAM PRESENTATION</a:t>
+              <a:t>CY376 RED TEAM BRIEFING</a:t>
             </a:r>
           </a:p>
           <a:p>
@@ -6544,12 +6606,12 @@
               </a:defRPr>
             </a:pPr>
             <a:r>
-              <a:t>Summary of Outcomes</a:t>
+              <a:t>Summary of Key Outcomes</a:t>
             </a:r>
           </a:p>
           <a:p>
             <a:pPr>
-              <a:defRPr sz="1400">
+              <a:defRPr sz="1350">
                 <a:solidFill>
                   <a:srgbClr val="1E293B"/>
                 </a:solidFill>
@@ -6562,7 +6624,7 @@
           </a:p>
           <a:p>
             <a:pPr>
-              <a:defRPr sz="1400">
+              <a:defRPr sz="1350">
                 <a:solidFill>
                   <a:srgbClr val="1E293B"/>
                 </a:solidFill>
@@ -6575,7 +6637,7 @@
           </a:p>
           <a:p>
             <a:pPr>
-              <a:defRPr sz="1400">
+              <a:defRPr sz="1350">
                 <a:solidFill>
                   <a:srgbClr val="1E293B"/>
                 </a:solidFill>
@@ -6588,7 +6650,7 @@
           </a:p>
           <a:p>
             <a:pPr>
-              <a:defRPr sz="1400">
+              <a:defRPr sz="1350">
                 <a:solidFill>
                   <a:srgbClr val="1E293B"/>
                 </a:solidFill>
@@ -6596,7 +6658,7 @@
               </a:defRPr>
             </a:pPr>
             <a:r>
-              <a:t>• Complete Deliverables Pushed: Written Report (DOCX/PDF), Execution Scripts, Evidence Logs, and Screenshots pushed to GitHub.</a:t>
+              <a:t>• Complete Deliverables Pushed: Written Report (DOCX/PDF), Presentation Slides (.pptx), Execution Scripts, Evidence Logs, and Screenshots pushed to GitHub.</a:t>
             </a:r>
           </a:p>
           <a:p>

</xml_diff>